<commit_message>
Polish pass from José's annotated feedback
- Hero: 'A pie de mostrador' becomes the title, the question a subtitle;
  'comercios locales' replaces 'pequeños comercios' (report, flyer, deck)
- Fix location chip: 5 Barcelona neighbourhoods + Santa Coloma de Gramenet
- Soften interview-time claim; move colour-identity note to footer only
- New positive section 'Primero, lo bueno' before the six signals
- Two-column signal cards: quotes fill the space, no dead gap
- Señal 05: WhatsApp reframed as the tool that earned its place
- Señal 06: add Mostaza VeriFactu quote; worry spans the whole spectrum
- Spectrum: INDO moved off 'memoria y papel'; wider, fuller fineprint
- Tensions: four to six, WhatsApp tension replaced by three new ones
  grounded in the n=8 synthesis
- Quotes framing: 'very close to what we were told' instead of verbatim

Co-Authored-By: Claude Fable 5 <noreply@anthropic.com>
</commit_message>
<xml_diff>
--- a/apiedemostrador-deck.pptx
+++ b/apiedemostrador-deck.pptx
@@ -1998,7 +1998,7 @@
                 <a:ea typeface="Trebuchet MS" pitchFamily="34" charset="-122"/>
                 <a:cs typeface="Trebuchet MS" pitchFamily="34" charset="-120"/>
               </a:rPr>
-              <a:t>, los pequeños comercios?</a:t>
+              <a:t>, los comercios locales?</a:t>
             </a:r>
             <a:endParaRPr lang="en-US" sz="4400" dirty="0"/>
           </a:p>
@@ -2172,7 +2172,7 @@
                 <a:ea typeface="Calibri" pitchFamily="34" charset="-122"/>
                 <a:cs typeface="Calibri" pitchFamily="34" charset="-120"/>
               </a:rPr>
-              <a:t>6 barrios y ciudades</a:t>
+              <a:t>5 barrios de BCN + Santa Coloma</a:t>
             </a:r>
             <a:endParaRPr lang="en-US" sz="1200" dirty="0"/>
           </a:p>
@@ -5330,7 +5330,7 @@
                 <a:ea typeface="Trebuchet MS" pitchFamily="34" charset="-122"/>
                 <a:cs typeface="Trebuchet MS" pitchFamily="34" charset="-120"/>
               </a:rPr>
-              <a:t>Citas literales</a:t>
+              <a:t>Citas casi textuales</a:t>
             </a:r>
             <a:endParaRPr lang="en-US" sz="1550" dirty="0"/>
           </a:p>
@@ -5372,7 +5372,7 @@
                 <a:ea typeface="Calibri" pitchFamily="34" charset="-122"/>
                 <a:cs typeface="Calibri" pitchFamily="34" charset="-120"/>
               </a:rPr>
-              <a:t>Todo lo entrecomillado se dijo en entrevista, palabra por palabra, y se atribuye solo por categoría de tienda.</a:t>
+              <a:t>Todo lo entrecomillado se dijo en entrevista, retocado solo lo mínimo para leerse bien, y se atribuye solo por categoría de tienda.</a:t>
             </a:r>
             <a:endParaRPr lang="en-US" sz="1250" dirty="0"/>
           </a:p>

</xml_diff>

<commit_message>
Add trilingual report and early contact form
</commit_message>
<xml_diff>
--- a/apiedemostrador-deck.pptx
+++ b/apiedemostrador-deck.pptx
@@ -2,20 +2,20 @@
 <file path=ppt/presentation.xml><?xml version="1.0" encoding="utf-8"?>
 <p:presentation xmlns:p="http://schemas.openxmlformats.org/presentationml/2006/main">
   <p:sldMasterIdLst>
-    <p:sldMasterId xmlns:r="http://schemas.openxmlformats.org/officeDocument/2006/relationships" id="2147483648" r:id="R4c02ebf633e84367"/>
+    <p:sldMasterId xmlns:r="http://schemas.openxmlformats.org/officeDocument/2006/relationships" id="2147483648" r:id="R59483edc17ea4182"/>
   </p:sldMasterIdLst>
   <p:notesMasterIdLst>
-    <p:notesMasterId xmlns:r="http://schemas.openxmlformats.org/officeDocument/2006/relationships" r:id="R13ec55158cae45d8"/>
+    <p:notesMasterId xmlns:r="http://schemas.openxmlformats.org/officeDocument/2006/relationships" r:id="R64efcf899ef74493"/>
   </p:notesMasterIdLst>
   <p:sldIdLst>
-    <p:sldId xmlns:r="http://schemas.openxmlformats.org/officeDocument/2006/relationships" id="256" r:id="Rb43cac6017da4b40"/>
-    <p:sldId xmlns:r="http://schemas.openxmlformats.org/officeDocument/2006/relationships" id="257" r:id="Rfcf8fc3859e4494e"/>
-    <p:sldId xmlns:r="http://schemas.openxmlformats.org/officeDocument/2006/relationships" id="258" r:id="Rcd80976b06e9422a"/>
-    <p:sldId xmlns:r="http://schemas.openxmlformats.org/officeDocument/2006/relationships" id="259" r:id="Rb3b9d563beef4eb7"/>
-    <p:sldId xmlns:r="http://schemas.openxmlformats.org/officeDocument/2006/relationships" id="260" r:id="Rf6fbb0a825be4944"/>
-    <p:sldId xmlns:r="http://schemas.openxmlformats.org/officeDocument/2006/relationships" id="261" r:id="Re934d9d10f2242f3"/>
-    <p:sldId xmlns:r="http://schemas.openxmlformats.org/officeDocument/2006/relationships" id="262" r:id="Rfe6549c2e55f4322"/>
-    <p:sldId xmlns:r="http://schemas.openxmlformats.org/officeDocument/2006/relationships" id="263" r:id="R3a271667f22d4666"/>
+    <p:sldId xmlns:r="http://schemas.openxmlformats.org/officeDocument/2006/relationships" id="256" r:id="Rbe4f883ad99e4b14"/>
+    <p:sldId xmlns:r="http://schemas.openxmlformats.org/officeDocument/2006/relationships" id="257" r:id="R1befb97ec0c943a1"/>
+    <p:sldId xmlns:r="http://schemas.openxmlformats.org/officeDocument/2006/relationships" id="258" r:id="R9f71c0dbe85b42a9"/>
+    <p:sldId xmlns:r="http://schemas.openxmlformats.org/officeDocument/2006/relationships" id="259" r:id="R8425f78e5cc64645"/>
+    <p:sldId xmlns:r="http://schemas.openxmlformats.org/officeDocument/2006/relationships" id="260" r:id="R0e8a1c0f2e054c62"/>
+    <p:sldId xmlns:r="http://schemas.openxmlformats.org/officeDocument/2006/relationships" id="261" r:id="R0c29af8592504ac5"/>
+    <p:sldId xmlns:r="http://schemas.openxmlformats.org/officeDocument/2006/relationships" id="262" r:id="Rf6d1cbc5c95d49a8"/>
+    <p:sldId xmlns:r="http://schemas.openxmlformats.org/officeDocument/2006/relationships" id="263" r:id="R6cb0aa772a374177"/>
   </p:sldIdLst>
   <p:sldSz cx="12192000" cy="6858000"/>
   <p:notesSz cx="6858000" cy="9144000"/>
@@ -1142,7 +1142,7 @@
   </p:cSld>
   <p:clrMap bg1="lt1" tx1="dk1" bg2="lt2" tx2="dk2" accent1="accent1" accent2="accent2" accent3="accent3" accent4="accent4" accent5="accent5" accent6="accent6" hlink="hlink" folHlink="folHlink"/>
   <p:sldLayoutIdLst>
-    <p:sldLayoutId xmlns:r="http://schemas.openxmlformats.org/officeDocument/2006/relationships" id="2147483649" r:id="R9bd7efa8a953462e"/>
+    <p:sldLayoutId xmlns:r="http://schemas.openxmlformats.org/officeDocument/2006/relationships" id="2147483649" r:id="R2fd12d0c22e34ffa"/>
   </p:sldLayoutIdLst>
   <p:hf sldNum="0" hdr="0" ftr="0" dt="0"/>
   <p:txStyles>
@@ -9335,7 +9335,7 @@
                 <a:latin typeface="Calibri"/>
                 <a:ea typeface="Calibri"/>
                 <a:cs typeface="Calibri"/>
-                <a:hlinkClick xmlns:r="http://schemas.openxmlformats.org/officeDocument/2006/relationships" r:id="R34ec270c43374357"/>
+                <a:hlinkClick xmlns:r="http://schemas.openxmlformats.org/officeDocument/2006/relationships" r:id="R85e5043880f64291"/>
               </a:rPr>
               <a:t>chpmoreno.github.io/apiedemostrador</a:t>
             </a:r>
@@ -9733,7 +9733,7 @@
                 <a:ea typeface="Calibri"/>
                 <a:cs typeface="Calibri"/>
               </a:rPr>
-              <a:t>Una preocupación operativa no demuestra disposición a pagar por una solución.</a:t>
+              <a:t>Una preocupación operativa no demuestra disposición a adoptar una solución tecnológica.</a:t>
             </a:r>
           </a:p>
         </p:txBody>

</xml_diff>